<commit_message>
Fix all review issues from devil's reviewer
Critical fixes:
- C1: Add smina/ADFRsuite binary install note to Workshop
- C2: Add PDBQT→SDF conversion code (Vina output gap)
- C3: Fix DataWarrior slide numbering (add 실습 7 label)

Major fixes:
- M1: ALK kinase group TKL → TK (RTK, not TKL)
- M2: exhaustiveness "Monte Carlo" → "ILS runs" (Vina uses ILS)
- M3: SkelSpheres "3D-aware" → "topological, 2D"
- M6: Add 실습 7 label to PyMOL color guide slide

Minor fixes:
- within (not w.), BEI ≈, Drug-Likeness description,
  단계 띄어쓰기, auto_size on all text frames

Co-Authored-By: Claude Opus 4.6 (1M context) <noreply@anthropic.com>
</commit_message>
<xml_diff>
--- a/DataWarrior_Tutorial.pptx
+++ b/DataWarrior_Tutorial.pptx
@@ -13235,7 +13235,7 @@
               </a:defRPr>
             </a:pPr>
             <a:r>
-              <a:t>• Fragment-based scoring (Muegge 방식)</a:t>
+              <a:t>• Fragment-based scoring (자체 fragment-based scoring)</a:t>
             </a:r>
           </a:p>
         </p:txBody>
@@ -16091,7 +16091,7 @@
               </a:defRPr>
             </a:pPr>
             <a:r>
-              <a:t>   Descriptor: SkelSpheres (3D-aware)</a:t>
+              <a:t>   Descriptor: SkelSpheres (topological, 2D)</a:t>
             </a:r>
           </a:p>
           <a:p>
@@ -16502,7 +16502,7 @@
               </a:defRPr>
             </a:pPr>
             <a:r>
-              <a:t>Kinase Panel 결과 분석</a:t>
+              <a:t>실습 7: Kinase Panel 결과 분석</a:t>
             </a:r>
           </a:p>
         </p:txBody>
@@ -16903,7 +16903,7 @@
               </a:defRPr>
             </a:pPr>
             <a:r>
-              <a:t>실습 5 (계속): R-Group Decomposition 상세</a:t>
+              <a:t>실습 5b: R-Group Decomposition 상세</a:t>
             </a:r>
           </a:p>
         </p:txBody>

</xml_diff>